<commit_message>
Ask demos 0 and 1 to say so when the repo states no rules
</commit_message>
<xml_diff>
--- a/github-copilot-app-extensibility.pptx
+++ b/github-copilot-app-extensibility.pptx
@@ -3887,7 +3887,7 @@
           <a:p>
             <a:r>
               <a:rPr lang="en-US" dirty="0"/>
-              <a:t>Demo 0, dos minutos. Pregunta primero, sin tocar código: «What rules should I follow when I change the UI in this repo?». En el paso 0 el agente no encuentra reglas (no hay AGENTS.md, CLAUDE.md ni copilot-instructions.md) y contesta con consejos genéricos deducidos de la estructura de carpetas: una respuesta razonable que no conoce al equipo. Tarda unos 40 segundos, casi todo las dos confirmaciones de lectura que pide el agente. Segundo golpe, opcional: el botón Clear, el mismo prompt que cierra la charla. La ejecución tarda entre 30 segundos y dos minutos y medio; en las pruebas el botón ya salió con Name y AutomationId y a veces el agente ejecutó la app, así que no lo vendas como un mal resultado: que salga bien no es una garantía. Si vas justo de tiempo, enseña el resultado ya ejecutado (respaldo: demo0-rules.png y demo0-baseline.png). Vamos a ir cerrando esos huecos, de menos a más. Las slides claras como esta son siempre demos: en cada una está el prompt, lo que debe verse y el proyecto en el que se ejecuta.</a:t>
+              <a:t>Demo 0, dos minutos. Pregunta primero, sin tocar código: «What rules should I follow when I change the UI in this repo? Answer in at most five short bullets. If the repo states no rules, say so.». La última frase le pide que lo diga en vez de presentar como reglas lo que deduce del código (sin ella, a veces enumera convenciones inferidas del CSS). En el paso 0 el agente no encuentra reglas (no hay AGENTS.md, CLAUDE.md ni copilot-instructions.md) y contesta con consejos genéricos deducidos de la estructura de carpetas: una respuesta razonable que no conoce al equipo. Tarda unos 40 segundos, casi todo las dos confirmaciones de lectura que pide el agente. Segundo golpe, opcional: el botón Clear, el mismo prompt que cierra la charla. La ejecución tarda entre 30 segundos y dos minutos y medio; en las pruebas el botón ya salió con Name y AutomationId y a veces el agente ejecutó la app, así que no lo vendas como un mal resultado: que salga bien no es una garantía. Si vas justo de tiempo, enseña el resultado ya ejecutado (respaldo: demo0-rules.png y demo0-baseline.png). Vamos a ir cerrando esos huecos, de menos a más. Las slides claras como esta son siempre demos: en cada una está el prompt, lo que debe verse y el proyecto en el que se ejecuta.</a:t>
             </a:r>
             <a:endParaRPr lang="en-US" dirty="0"/>
           </a:p>
@@ -4063,7 +4063,7 @@
           <a:p>
             <a:r>
               <a:rPr lang="en-US" dirty="0"/>
-              <a:t>Demo 1, dos minutos. La misma pregunta y el mismo modelo, con otra respuesta: ahora el agente lista las reglas del equipo (Name y AutomationId iguales, PascalCase con el tipo de control, no cambiar un AutomationId existente, texto visible en inglés y el comando de compilación) porque lee .github/copilot-instructions.md al empezar la sesión. Antes tenía que adivinar y ahora lo sabe, y eso es lo que hay que subrayar. Segundo golpe, opcional: el botón Clear. El código puede salir igual que en la demo 0, pero ahora es una norma del repo y no depende de la suerte. Respaldo: demo1-rules.png. Si el agente dice que no recibió instrucciones, comprueba que respondiste al aviso de confianza y abre una sesión nueva (véase demos/01-instructions.txt). Mensaje de cierre: las instrucciones sirven para normas, no para procedimientos. Para procedimientos, el siguiente escalón.</a:t>
+              <a:t>Demo 1, dos minutos. La misma pregunta (con la misma frase final, «If the repo states no rules, say so.», que aquí no cambia nada porque el repo sí declara reglas) y el mismo modelo, con otra respuesta: ahora el agente lista las reglas del equipo (Name y AutomationId iguales, PascalCase con el tipo de control, no cambiar un AutomationId existente, texto visible en inglés y el comando de compilación) porque lee .github/copilot-instructions.md al empezar la sesión. Antes tenía que adivinar y ahora lo sabe, y eso es lo que hay que subrayar. Segundo golpe, opcional: el botón Clear. El código puede salir igual que en la demo 0, pero ahora es una norma del repo y no depende de la suerte. Respaldo: demo1-rules.png. Si el agente dice que no recibió instrucciones, comprueba que respondiste al aviso de confianza y abre una sesión nueva (véase demos/01-instructions.txt). Mensaje de cierre: las instrucciones sirven para normas, no para procedimientos. Para procedimientos, el siguiente escalón.</a:t>
             </a:r>
             <a:endParaRPr lang="en-US" dirty="0"/>
           </a:p>
@@ -36908,7 +36908,7 @@
         <p:spPr>
           <a:xfrm>
             <a:off x="5583783" y="2550071"/>
-            <a:ext cx="5707659" cy="482600"/>
+            <a:ext cx="5707659" cy="685800"/>
           </a:xfrm>
           <a:prstGeom prst="rect">
             <a:avLst/>
@@ -36937,7 +36937,7 @@
                 <a:ea typeface="JetBrains Mono" pitchFamily="49" charset="-122"/>
                 <a:cs typeface="JetBrains Mono" pitchFamily="49" charset="-120"/>
               </a:rPr>
-              <a:t>What rules should I follow when I change the UI in this repo? Answer in at most five short bullets.</a:t>
+              <a:t>What rules should I follow when I change the UI in this repo? Answer in at most five short bullets. If the repo states no rules, say so.</a:t>
             </a:r>
             <a:endParaRPr lang="en-US" sz="1200" dirty="0"/>
           </a:p>
@@ -36958,7 +36958,7 @@
         </p:blipFill>
         <p:spPr>
           <a:xfrm>
-            <a:off x="5583783" y="3108871"/>
+            <a:off x="5583783" y="3337471"/>
             <a:ext cx="5541417" cy="6350"/>
           </a:xfrm>
           <a:prstGeom prst="rect">
@@ -36974,7 +36974,7 @@
         </p:nvSpPr>
         <p:spPr>
           <a:xfrm>
-            <a:off x="5583783" y="3216821"/>
+            <a:off x="5583783" y="3445421"/>
             <a:ext cx="5707659" cy="238720"/>
           </a:xfrm>
           <a:prstGeom prst="rect">
@@ -37018,7 +37018,7 @@
         </p:nvSpPr>
         <p:spPr>
           <a:xfrm>
-            <a:off x="5583783" y="3531741"/>
+            <a:off x="5583783" y="3760341"/>
             <a:ext cx="5707659" cy="558800"/>
           </a:xfrm>
           <a:prstGeom prst="rect">
@@ -38221,7 +38221,7 @@
         <p:spPr>
           <a:xfrm>
             <a:off x="5583783" y="2550071"/>
-            <a:ext cx="5707659" cy="482600"/>
+            <a:ext cx="5707659" cy="685800"/>
           </a:xfrm>
           <a:prstGeom prst="rect">
             <a:avLst/>
@@ -38250,7 +38250,7 @@
                 <a:ea typeface="JetBrains Mono" pitchFamily="49" charset="-122"/>
                 <a:cs typeface="JetBrains Mono" pitchFamily="49" charset="-120"/>
               </a:rPr>
-              <a:t>What rules should I follow when I change the UI in this repo? Answer in at most five short bullets.</a:t>
+              <a:t>What rules should I follow when I change the UI in this repo? Answer in at most five short bullets. If the repo states no rules, say so.</a:t>
             </a:r>
             <a:endParaRPr lang="en-US" sz="1200" dirty="0"/>
           </a:p>
@@ -38271,7 +38271,7 @@
         </p:blipFill>
         <p:spPr>
           <a:xfrm>
-            <a:off x="5583783" y="3108871"/>
+            <a:off x="5583783" y="3337471"/>
             <a:ext cx="5541417" cy="6350"/>
           </a:xfrm>
           <a:prstGeom prst="rect">
@@ -38287,7 +38287,7 @@
         </p:nvSpPr>
         <p:spPr>
           <a:xfrm>
-            <a:off x="5583783" y="3216821"/>
+            <a:off x="5583783" y="3445421"/>
             <a:ext cx="5707659" cy="238720"/>
           </a:xfrm>
           <a:prstGeom prst="rect">
@@ -38331,7 +38331,7 @@
         </p:nvSpPr>
         <p:spPr>
           <a:xfrm>
-            <a:off x="5583783" y="3531741"/>
+            <a:off x="5583783" y="3760341"/>
             <a:ext cx="5707659" cy="558800"/>
           </a:xfrm>
           <a:prstGeom prst="rect">

</xml_diff>

<commit_message>
Lead demo 1's expected result with the rules demo 0 cannot guess
</commit_message>
<xml_diff>
--- a/github-copilot-app-extensibility.pptx
+++ b/github-copilot-app-extensibility.pptx
@@ -4063,7 +4063,7 @@
           <a:p>
             <a:r>
               <a:rPr lang="en-US" dirty="0"/>
-              <a:t>Demo 1, dos minutos. La misma pregunta (con la misma frase final, «If the repo states no rules, say so.», que aquí no cambia nada porque el repo sí declara reglas) y el mismo modelo, con otra respuesta: ahora el agente lista las reglas del equipo (Name y AutomationId iguales, PascalCase con el tipo de control, no cambiar un AutomationId existente, texto visible en inglés y el comando de compilación) porque lee .github/copilot-instructions.md al empezar la sesión. Antes tenía que adivinar y ahora lo sabe, y eso es lo que hay que subrayar. Segundo golpe, opcional: el botón Clear. El código puede salir igual que en la demo 0, pero ahora es una norma del repo y no depende de la suerte. Respaldo: demo1-rules.png. Si el agente dice que no recibió instrucciones, comprueba que respondiste al aviso de confianza y abre una sesión nueva (véase demos/01-instructions.txt). Mensaje de cierre: las instrucciones sirven para normas, no para procedimientos. Para procedimientos, el siguiente escalón.</a:t>
+              <a:t>Demo 1, dos minutos. La misma pregunta (con la misma frase final, «If the repo states no rules, say so.», que aquí no cambia nada porque el repo sí declara reglas) y el mismo modelo, con otra respuesta: ahora el agente lista las reglas del equipo, y lo que cuenta es lo que la demo 0 no podía adivinar: ids en PascalCase que terminan con el tipo de control (GreetButton), no cambiar nunca un AutomationId existente, texto visible en inglés y el comando de compilación, además de Name y AutomationId iguales. Las lee de .github/copilot-instructions.md al empezar la sesión. Si en la demo 0 salió algo sobre AutomationId, era una pista de la documentación del repo, no una norma. Antes tenía que adivinar y ahora lo sabe, y eso es lo que hay que subrayar. Segundo golpe, opcional: el botón Clear. El código puede salir igual que en la demo 0, pero ahora es una norma del repo y no depende de la suerte. Respaldo: demo1-rules.png. Si el agente dice que no recibió instrucciones, comprueba que respondiste al aviso de confianza y abre una sesión nueva (véase demos/01-instructions.txt). Mensaje de cierre: las instrucciones sirven para normas, no para procedimientos. Para procedimientos, el siguiente escalón.</a:t>
             </a:r>
             <a:endParaRPr lang="en-US" dirty="0"/>
           </a:p>
@@ -38361,7 +38361,7 @@
                 <a:ea typeface="IBM Plex Sans" pitchFamily="34" charset="-122"/>
                 <a:cs typeface="IBM Plex Sans" pitchFamily="34" charset="-120"/>
               </a:rPr>
-              <a:t>It lists our rules: Name and AutomationId, never change an ID, English text, the build command.</a:t>
+              <a:t>It lists our rules: PascalCase ids ending with the control type, never change an id, English text, the build command.</a:t>
             </a:r>
             <a:endParaRPr lang="en-US" sz="1500" dirty="0"/>
           </a:p>

</xml_diff>